<commit_message>
Standardize all offshore rates to $72 CAD/h across resource plans
Traditional SDLC: $663K-890K (was $905K-1.18M)
EliteA: $344K (was $408K), ROI: 19,270% (was 16,150%)
Updated: Slides 11-12, assumptions, stats bar, BUSINESS_PLAN.md Sections 6.2-6.4

https://claude.ai/code/session_01T8paccBrcfsQU51qHUFnAt
</commit_message>
<xml_diff>
--- a/docs/CTC_Mobile_Wishlist_Business_Case.pptx
+++ b/docs/CTC_Mobile_Wishlist_Business_Case.pptx
@@ -6548,7 +6548,7 @@
               </a:defRPr>
             </a:pPr>
             <a:r>
-              <a:t>$130</a:t>
+              <a:t>$72</a:t>
             </a:r>
           </a:p>
         </p:txBody>
@@ -6618,7 +6618,7 @@
               </a:defRPr>
             </a:pPr>
             <a:r>
-              <a:t>$208K-250K</a:t>
+              <a:t>$115K-138K</a:t>
             </a:r>
           </a:p>
         </p:txBody>
@@ -6801,7 +6801,7 @@
               </a:defRPr>
             </a:pPr>
             <a:r>
-              <a:t>$130</a:t>
+              <a:t>$72</a:t>
             </a:r>
           </a:p>
         </p:txBody>
@@ -6871,7 +6871,7 @@
               </a:defRPr>
             </a:pPr>
             <a:r>
-              <a:t>$208K-250K</a:t>
+              <a:t>$115K-138K</a:t>
             </a:r>
           </a:p>
         </p:txBody>
@@ -7054,7 +7054,7 @@
               </a:defRPr>
             </a:pPr>
             <a:r>
-              <a:t>$95</a:t>
+              <a:t>$72</a:t>
             </a:r>
           </a:p>
         </p:txBody>
@@ -7124,7 +7124,7 @@
               </a:defRPr>
             </a:pPr>
             <a:r>
-              <a:t>$46K-61K</a:t>
+              <a:t>$35K-46K</a:t>
             </a:r>
           </a:p>
         </p:txBody>
@@ -7307,7 +7307,7 @@
               </a:defRPr>
             </a:pPr>
             <a:r>
-              <a:t>$110</a:t>
+              <a:t>$72</a:t>
             </a:r>
           </a:p>
         </p:txBody>
@@ -7377,7 +7377,7 @@
               </a:defRPr>
             </a:pPr>
             <a:r>
-              <a:t>$53K-70K</a:t>
+              <a:t>$35K-46K</a:t>
             </a:r>
           </a:p>
         </p:txBody>
@@ -7560,7 +7560,7 @@
               </a:defRPr>
             </a:pPr>
             <a:r>
-              <a:t>$140</a:t>
+              <a:t>$72</a:t>
             </a:r>
           </a:p>
         </p:txBody>
@@ -7630,7 +7630,7 @@
               </a:defRPr>
             </a:pPr>
             <a:r>
-              <a:t>$56K-67K</a:t>
+              <a:t>$29K-35K</a:t>
             </a:r>
           </a:p>
         </p:txBody>
@@ -7813,7 +7813,7 @@
               </a:defRPr>
             </a:pPr>
             <a:r>
-              <a:t>$905K-1.18M</a:t>
+              <a:t>$663K-890K</a:t>
             </a:r>
           </a:p>
         </p:txBody>
@@ -9511,7 +9511,7 @@
               </a:defRPr>
             </a:pPr>
             <a:r>
-              <a:t>$130</a:t>
+              <a:t>$72</a:t>
             </a:r>
           </a:p>
         </p:txBody>
@@ -9581,7 +9581,7 @@
               </a:defRPr>
             </a:pPr>
             <a:r>
-              <a:t>$62K</a:t>
+              <a:t>$35K</a:t>
             </a:r>
           </a:p>
         </p:txBody>
@@ -9764,7 +9764,7 @@
               </a:defRPr>
             </a:pPr>
             <a:r>
-              <a:t>$130</a:t>
+              <a:t>$72</a:t>
             </a:r>
           </a:p>
         </p:txBody>
@@ -9834,7 +9834,7 @@
               </a:defRPr>
             </a:pPr>
             <a:r>
-              <a:t>$52K</a:t>
+              <a:t>$29K</a:t>
             </a:r>
           </a:p>
         </p:txBody>
@@ -10523,7 +10523,7 @@
               </a:defRPr>
             </a:pPr>
             <a:r>
-              <a:t>$100</a:t>
+              <a:t>$72</a:t>
             </a:r>
           </a:p>
         </p:txBody>
@@ -10593,7 +10593,7 @@
               </a:defRPr>
             </a:pPr>
             <a:r>
-              <a:t>$20K</a:t>
+              <a:t>$14K</a:t>
             </a:r>
           </a:p>
         </p:txBody>
@@ -10776,7 +10776,7 @@
               </a:defRPr>
             </a:pPr>
             <a:r>
-              <a:t>$140</a:t>
+              <a:t>$72</a:t>
             </a:r>
           </a:p>
         </p:txBody>
@@ -10846,7 +10846,7 @@
               </a:defRPr>
             </a:pPr>
             <a:r>
-              <a:t>$17K</a:t>
+              <a:t>$9K</a:t>
             </a:r>
           </a:p>
         </p:txBody>
@@ -11029,7 +11029,7 @@
               </a:defRPr>
             </a:pPr>
             <a:r>
-              <a:t>$408K</a:t>
+              <a:t>$344K</a:t>
             </a:r>
           </a:p>
         </p:txBody>
@@ -11454,7 +11454,7 @@
               </a:defRPr>
             </a:pPr>
             <a:r>
-              <a:t>EliteA saves $500K-770K CAD (55-65%)  |  50% fewer human FTEs (5 vs 10)  |  4-6 months faster  |  AI handles ~70% of code, tests, and docs</a:t>
+              <a:t>EliteA saves $320K-550K CAD (48-61%)  |  50% fewer human FTEs (5 vs 10)  |  4-6 months faster  |  AI handles ~70% of code, tests, and docs</a:t>
             </a:r>
           </a:p>
         </p:txBody>
@@ -11628,7 +11628,7 @@
               </a:defRPr>
             </a:pPr>
             <a:r>
-              <a:t>All amounts in CAD  |  Agentic AI SDLC reduces cost by ~60% and timeline by ~50%</a:t>
+              <a:t>All amounts in CAD  |  Agentic AI SDLC reduces cost by ~50% and timeline by ~50%</a:t>
             </a:r>
           </a:p>
         </p:txBody>
@@ -11943,7 +11943,7 @@
               </a:defRPr>
             </a:pPr>
             <a:r>
-              <a:t>$264K-317K</a:t>
+              <a:t>$146K-176K</a:t>
             </a:r>
           </a:p>
         </p:txBody>
@@ -12048,7 +12048,7 @@
               </a:defRPr>
             </a:pPr>
             <a:r>
-              <a:t>$264K-317K</a:t>
+              <a:t>$146K-176K</a:t>
             </a:r>
           </a:p>
         </p:txBody>
@@ -12153,7 +12153,7 @@
               </a:defRPr>
             </a:pPr>
             <a:r>
-              <a:t>$99K-131K</a:t>
+              <a:t>$70K-92K</a:t>
             </a:r>
           </a:p>
         </p:txBody>
@@ -12258,7 +12258,7 @@
               </a:defRPr>
             </a:pPr>
             <a:r>
-              <a:t>$56K-67K</a:t>
+              <a:t>$29K-35K</a:t>
             </a:r>
           </a:p>
         </p:txBody>
@@ -12511,7 +12511,7 @@
               </a:defRPr>
             </a:pPr>
             <a:r>
-              <a:t>$905K-1.18M</a:t>
+              <a:t>$663K-890K</a:t>
             </a:r>
           </a:p>
         </p:txBody>
@@ -12756,7 +12756,7 @@
               </a:defRPr>
             </a:pPr>
             <a:r>
-              <a:t>$114K</a:t>
+              <a:t>$64K</a:t>
             </a:r>
           </a:p>
         </p:txBody>
@@ -12966,7 +12966,7 @@
               </a:defRPr>
             </a:pPr>
             <a:r>
-              <a:t>$37K</a:t>
+              <a:t>$23K</a:t>
             </a:r>
           </a:p>
         </p:txBody>
@@ -13114,7 +13114,7 @@
               </a:defRPr>
             </a:pPr>
             <a:r>
-              <a:t>$408K</a:t>
+              <a:t>$344K</a:t>
             </a:r>
           </a:p>
         </p:txBody>
@@ -13464,7 +13464,7 @@
               </a:defRPr>
             </a:pPr>
             <a:r>
-              <a:t>$408K CAD</a:t>
+              <a:t>$344K CAD</a:t>
             </a:r>
           </a:p>
         </p:txBody>
@@ -13604,7 +13604,7 @@
               </a:defRPr>
             </a:pPr>
             <a:r>
-              <a:t>16,150%</a:t>
+              <a:t>19,270%</a:t>
             </a:r>
           </a:p>
         </p:txBody>
@@ -13682,7 +13682,7 @@
               </a:defRPr>
             </a:pPr>
             <a:r>
-              <a:t>EliteA saves $500K-770K CAD and 4+ months vs. traditional</a:t>
+              <a:t>EliteA saves $320K-550K CAD and 4+ months vs. traditional</a:t>
             </a:r>
           </a:p>
         </p:txBody>
@@ -14048,7 +14048,7 @@
               </a:defRPr>
             </a:pPr>
             <a:r>
-              <a:t>  Offshore rates (CAD/h): Sr Dev $130, QA $95-110, DevOps $140</a:t>
+              <a:t>  Offshore rates (CAD/h): All resources $72</a:t>
             </a:r>
           </a:p>
           <a:p>
@@ -18892,7 +18892,7 @@
               </a:defRPr>
             </a:pPr>
             <a:r>
-              <a:t>$408K</a:t>
+              <a:t>$344K</a:t>
             </a:r>
           </a:p>
         </p:txBody>
@@ -19032,7 +19032,7 @@
               </a:defRPr>
             </a:pPr>
             <a:r>
-              <a:t>16,150%</a:t>
+              <a:t>19,270%</a:t>
             </a:r>
           </a:p>
         </p:txBody>

</xml_diff>